<commit_message>
Title slide: top 10 at the Paytm Build for India AI Hackathon, Mumbai
</commit_message>
<xml_diff>
--- a/docs/BAHI-Final.pptx
+++ b/docs/BAHI-Final.pptx
@@ -3159,106 +3159,19 @@
       </p:sp>
       <p:sp>
         <p:nvSpPr>
-          <p:cNvPr id="4" name="TextBox 3"/>
-          <p:cNvSpPr txBox="1"/>
-          <p:nvPr/>
-        </p:nvSpPr>
-        <p:spPr>
-          <a:xfrm>
-            <a:off x="566928" y="1325880"/>
-            <a:ext cx="6400800" cy="4206240"/>
-          </a:xfrm>
-          <a:prstGeom prst="rect">
-            <a:avLst/>
-          </a:prstGeom>
-          <a:noFill/>
-        </p:spPr>
-        <p:txBody>
-          <a:bodyPr wrap="square" lIns="0" rIns="0" tIns="0" bIns="0" anchor="t">
-            <a:spAutoFit/>
-          </a:bodyPr>
-          <a:lstStyle/>
-          <a:p>
-            <a:pPr>
-              <a:lnSpc>
-                <a:spcPct val="95000"/>
-              </a:lnSpc>
-              <a:spcBef>
-                <a:spcPts val="0"/>
-              </a:spcBef>
-              <a:spcAft>
-                <a:spcPts val="0"/>
-              </a:spcAft>
-            </a:pPr>
-            <a:r>
-              <a:rPr sz="7000" b="1">
-                <a:solidFill>
-                  <a:srgbClr val="FFFFFF"/>
-                </a:solidFill>
-                <a:latin typeface="Arial"/>
-              </a:rPr>
-              <a:t>BAHI</a:t>
-            </a:r>
-          </a:p>
-          <a:p>
-            <a:pPr>
-              <a:lnSpc>
-                <a:spcPct val="110000"/>
-              </a:lnSpc>
-              <a:spcBef>
-                <a:spcPts val="1000"/>
-              </a:spcBef>
-              <a:spcAft>
-                <a:spcPts val="0"/>
-              </a:spcAft>
-            </a:pPr>
-            <a:r>
-              <a:rPr sz="2800" b="1">
-                <a:solidFill>
-                  <a:srgbClr val="FFFFFF"/>
-                </a:solidFill>
-                <a:latin typeface="Arial"/>
-              </a:rPr>
-              <a:t>The udhaar book both sides can see.</a:t>
-            </a:r>
-          </a:p>
-          <a:p>
-            <a:pPr>
-              <a:lnSpc>
-                <a:spcPct val="140000"/>
-              </a:lnSpc>
-              <a:spcBef>
-                <a:spcPts val="1800"/>
-              </a:spcBef>
-              <a:spcAft>
-                <a:spcPts val="0"/>
-              </a:spcAft>
-            </a:pPr>
-            <a:r>
-              <a:rPr sz="1500" b="0">
-                <a:solidFill>
-                  <a:srgbClr val="C9D8EE"/>
-                </a:solidFill>
-                <a:latin typeface="Arial"/>
-              </a:rPr>
-              <a:t>The customer scans the shop’s udhaar QR, or asks for udhaar on her own phone. The shopkeeper tells his AI munshi the amount, and nothing is written until both sides say yes. Every night, plain code decides who actually needs a reminder.</a:t>
-            </a:r>
-          </a:p>
-        </p:txBody>
-      </p:sp>
-      <p:sp>
-        <p:nvSpPr>
-          <p:cNvPr id="5" name="Rectangle 4"/>
+          <p:cNvPr id="4" name="Rounded Rectangle 3"/>
           <p:cNvSpPr/>
           <p:nvPr/>
         </p:nvSpPr>
         <p:spPr>
           <a:xfrm>
-            <a:off x="566928" y="5074920"/>
-            <a:ext cx="457200" cy="38100"/>
-          </a:xfrm>
-          <a:prstGeom prst="rect">
-            <a:avLst/>
+            <a:off x="566928" y="777240"/>
+            <a:ext cx="4846320" cy="329184"/>
+          </a:xfrm>
+          <a:prstGeom prst="roundRect">
+            <a:avLst>
+              <a:gd name="adj" fmla="val 50000"/>
+            </a:avLst>
           </a:prstGeom>
           <a:solidFill>
             <a:srgbClr val="00BAF2"/>
@@ -3277,14 +3190,59 @@
       </p:sp>
       <p:sp>
         <p:nvSpPr>
+          <p:cNvPr id="5" name="TextBox 4"/>
+          <p:cNvSpPr txBox="1"/>
+          <p:nvPr/>
+        </p:nvSpPr>
+        <p:spPr>
+          <a:xfrm>
+            <a:off x="566928" y="777240"/>
+            <a:ext cx="4846320" cy="329184"/>
+          </a:xfrm>
+          <a:prstGeom prst="rect">
+            <a:avLst/>
+          </a:prstGeom>
+          <a:noFill/>
+        </p:spPr>
+        <p:txBody>
+          <a:bodyPr wrap="square" lIns="0" rIns="0" tIns="0" bIns="0" anchor="ctr">
+            <a:spAutoFit/>
+          </a:bodyPr>
+          <a:lstStyle/>
+          <a:p>
+            <a:pPr algn="ctr">
+              <a:lnSpc>
+                <a:spcPct val="100000"/>
+              </a:lnSpc>
+              <a:spcBef>
+                <a:spcPts val="0"/>
+              </a:spcBef>
+              <a:spcAft>
+                <a:spcPts val="0"/>
+              </a:spcAft>
+            </a:pPr>
+            <a:r>
+              <a:rPr sz="1100" b="1" spc="80">
+                <a:solidFill>
+                  <a:srgbClr val="002970"/>
+                </a:solidFill>
+                <a:latin typeface="Arial"/>
+              </a:rPr>
+              <a:t>TOP 10  ·  PAYTM BUILD FOR INDIA AI HACKATHON, MUMBAI</a:t>
+            </a:r>
+          </a:p>
+        </p:txBody>
+      </p:sp>
+      <p:sp>
+        <p:nvSpPr>
           <p:cNvPr id="6" name="TextBox 5"/>
           <p:cNvSpPr txBox="1"/>
           <p:nvPr/>
         </p:nvSpPr>
         <p:spPr>
           <a:xfrm>
-            <a:off x="566928" y="5257800"/>
-            <a:ext cx="6675120" cy="731520"/>
+            <a:off x="566928" y="1325880"/>
+            <a:ext cx="6400800" cy="4206240"/>
           </a:xfrm>
           <a:prstGeom prst="rect">
             <a:avLst/>
@@ -3299,6 +3257,124 @@
           <a:p>
             <a:pPr>
               <a:lnSpc>
+                <a:spcPct val="95000"/>
+              </a:lnSpc>
+              <a:spcBef>
+                <a:spcPts val="0"/>
+              </a:spcBef>
+              <a:spcAft>
+                <a:spcPts val="0"/>
+              </a:spcAft>
+            </a:pPr>
+            <a:r>
+              <a:rPr sz="7000" b="1">
+                <a:solidFill>
+                  <a:srgbClr val="FFFFFF"/>
+                </a:solidFill>
+                <a:latin typeface="Arial"/>
+              </a:rPr>
+              <a:t>BAHI</a:t>
+            </a:r>
+          </a:p>
+          <a:p>
+            <a:pPr>
+              <a:lnSpc>
+                <a:spcPct val="110000"/>
+              </a:lnSpc>
+              <a:spcBef>
+                <a:spcPts val="1000"/>
+              </a:spcBef>
+              <a:spcAft>
+                <a:spcPts val="0"/>
+              </a:spcAft>
+            </a:pPr>
+            <a:r>
+              <a:rPr sz="2800" b="1">
+                <a:solidFill>
+                  <a:srgbClr val="FFFFFF"/>
+                </a:solidFill>
+                <a:latin typeface="Arial"/>
+              </a:rPr>
+              <a:t>The udhaar book both sides can see.</a:t>
+            </a:r>
+          </a:p>
+          <a:p>
+            <a:pPr>
+              <a:lnSpc>
+                <a:spcPct val="140000"/>
+              </a:lnSpc>
+              <a:spcBef>
+                <a:spcPts val="1800"/>
+              </a:spcBef>
+              <a:spcAft>
+                <a:spcPts val="0"/>
+              </a:spcAft>
+            </a:pPr>
+            <a:r>
+              <a:rPr sz="1500" b="0">
+                <a:solidFill>
+                  <a:srgbClr val="C9D8EE"/>
+                </a:solidFill>
+                <a:latin typeface="Arial"/>
+              </a:rPr>
+              <a:t>The customer scans the shop’s udhaar QR, or asks for udhaar on her own phone. The shopkeeper tells his AI munshi the amount, and nothing is written until both sides say yes. Every night, plain code decides who actually needs a reminder.</a:t>
+            </a:r>
+          </a:p>
+        </p:txBody>
+      </p:sp>
+      <p:sp>
+        <p:nvSpPr>
+          <p:cNvPr id="7" name="Rectangle 6"/>
+          <p:cNvSpPr/>
+          <p:nvPr/>
+        </p:nvSpPr>
+        <p:spPr>
+          <a:xfrm>
+            <a:off x="566928" y="5074920"/>
+            <a:ext cx="457200" cy="38100"/>
+          </a:xfrm>
+          <a:prstGeom prst="rect">
+            <a:avLst/>
+          </a:prstGeom>
+          <a:solidFill>
+            <a:srgbClr val="00BAF2"/>
+          </a:solidFill>
+          <a:ln>
+            <a:noFill/>
+          </a:ln>
+        </p:spPr>
+        <p:txBody>
+          <a:bodyPr rtlCol="0" anchor="ctr"/>
+          <a:lstStyle/>
+          <a:p>
+            <a:pPr algn="ctr"/>
+          </a:p>
+        </p:txBody>
+      </p:sp>
+      <p:sp>
+        <p:nvSpPr>
+          <p:cNvPr id="8" name="TextBox 7"/>
+          <p:cNvSpPr txBox="1"/>
+          <p:nvPr/>
+        </p:nvSpPr>
+        <p:spPr>
+          <a:xfrm>
+            <a:off x="566928" y="5257800"/>
+            <a:ext cx="6675120" cy="731520"/>
+          </a:xfrm>
+          <a:prstGeom prst="rect">
+            <a:avLst/>
+          </a:prstGeom>
+          <a:noFill/>
+        </p:spPr>
+        <p:txBody>
+          <a:bodyPr wrap="square" lIns="0" rIns="0" tIns="0" bIns="0" anchor="t">
+            <a:spAutoFit/>
+          </a:bodyPr>
+          <a:lstStyle/>
+          <a:p>
+            <a:pPr>
+              <a:lnSpc>
                 <a:spcPct val="130000"/>
               </a:lnSpc>
               <a:spcBef>
@@ -3359,14 +3435,14 @@
                 </a:solidFill>
                 <a:latin typeface="Arial"/>
               </a:rPr>
-              <a:t>Team Hustlers</a:t>
-            </a:r>
-          </a:p>
-        </p:txBody>
-      </p:sp>
-      <p:sp>
-        <p:nvSpPr>
-          <p:cNvPr id="7" name="Rounded Rectangle 6"/>
+              <a:t>Team Hustlers  ·  picked by the Paytm panel as a top 10 project</a:t>
+            </a:r>
+          </a:p>
+        </p:txBody>
+      </p:sp>
+      <p:sp>
+        <p:nvSpPr>
+          <p:cNvPr id="9" name="Rounded Rectangle 8"/>
           <p:cNvSpPr/>
           <p:nvPr/>
         </p:nvSpPr>
@@ -3399,7 +3475,7 @@
       </p:sp>
       <p:pic>
         <p:nvPicPr>
-          <p:cNvPr id="8" name="Picture 7" descr="m-popup.png"/>
+          <p:cNvPr id="10" name="Picture 9" descr="m-popup.png"/>
           <p:cNvPicPr>
             <a:picLocks noChangeAspect="1"/>
           </p:cNvPicPr>
@@ -3423,7 +3499,7 @@
       </p:pic>
       <p:sp>
         <p:nvSpPr>
-          <p:cNvPr id="9" name="Rounded Rectangle 8"/>
+          <p:cNvPr id="11" name="Rounded Rectangle 10"/>
           <p:cNvSpPr/>
           <p:nvPr/>
         </p:nvSpPr>
@@ -3456,7 +3532,7 @@
       </p:sp>
       <p:pic>
         <p:nvPicPr>
-          <p:cNvPr id="10" name="Picture 9" descr="c-chat.png"/>
+          <p:cNvPr id="12" name="Picture 11" descr="c-chat.png"/>
           <p:cNvPicPr>
             <a:picLocks noChangeAspect="1"/>
           </p:cNvPicPr>
@@ -3480,7 +3556,7 @@
       </p:pic>
       <p:sp>
         <p:nvSpPr>
-          <p:cNvPr id="11" name="TextBox 10"/>
+          <p:cNvPr id="13" name="TextBox 12"/>
           <p:cNvSpPr txBox="1"/>
           <p:nvPr/>
         </p:nvSpPr>

</xml_diff>